<commit_message>
Make the deck's own numbers agree, and link the real repo
Slide 5 says "Human reviews 360 / Agreed gold labels 173". Slide 6 said
"173 human labels" for the same corpus, so the deck contradicted itself one
page apart - and 173 is the agreed set, not the review count. Slide 6 now
reads the same way slide 5 does.

Slide 6's footer said "GitHub: SANKET - AI-powered SIF precursor detection",
which is a repo description sitting where a judge expects a link, next to a
live URL that is one. It now carries the URL. The repo has been renamed from
SIH-2026 to SANKET; the old path still redirects, but the slide should show
where the code actually lives.

Co-Authored-By: Claude Opus 5 (1M context) <noreply@anthropic.com>
</commit_message>
<xml_diff>
--- a/docs/SANKET-SIH2026-Idea-Submission.pptx
+++ b/docs/SANKET-SIH2026-Idea-Submission.pptx
@@ -11186,7 +11186,7 @@
                 </a:solidFill>
                 <a:latin typeface="Arial"/>
               </a:rPr>
-              <a:t>150 synthetic safety reports  +  30 OSHA severe-injury reports  ·  173 human labels</a:t>
+              <a:t>150 synthetic safety reports  +  30 OSHA severe-injury reports  ·  360 reviews by two people  ·  173 agreed gold labels</a:t>
             </a:r>
           </a:p>
         </p:txBody>
@@ -11825,7 +11825,7 @@
                 </a:solidFill>
                 <a:latin typeface="Arial"/>
               </a:rPr>
-              <a:t>Live prototype:  https://sanket-frontend.onrender.com        GitHub:  SANKET — AI-powered SIF precursor detection</a:t>
+              <a:t>Live prototype:  https://sanket-frontend.onrender.com        Code:  github.com/sukanya-2006/SANKET</a:t>
             </a:r>
           </a:p>
         </p:txBody>

</xml_diff>